<commit_message>
add tags for own and other
</commit_message>
<xml_diff>
--- a/source/Instructor Progress Test 3 Grams/Instructor Progress Test 3 Grams.pptx
+++ b/source/Instructor Progress Test 3 Grams/Instructor Progress Test 3 Grams.pptx
@@ -5,12 +5,12 @@
     <p:sldMasterId id="2147483648" r:id="rId1"/>
   </p:sldMasterIdLst>
   <p:sldIdLst>
-    <p:sldId id="256" r:id="rId7"/>
-    <p:sldId id="257" r:id="rId8"/>
-    <p:sldId id="258" r:id="rId9"/>
-    <p:sldId id="259" r:id="rId10"/>
+    <p:sldId id="256" r:id="rId2"/>
+    <p:sldId id="257" r:id="rId3"/>
+    <p:sldId id="258" r:id="rId4"/>
+    <p:sldId id="259" r:id="rId5"/>
   </p:sldIdLst>
-  <p:sldSz cx="12188952" cy="6858000" type="screen4x3"/>
+  <p:sldSz cx="12188825" cy="6858000"/>
   <p:notesSz cx="6858000" cy="9144000"/>
   <p:defaultTextStyle>
     <a:defPPr>
@@ -107,6 +107,22 @@
       </a:defRPr>
     </a:lvl9pPr>
   </p:defaultTextStyle>
+  <p:extLst>
+    <p:ext uri="{EFAFB233-063F-42B5-8137-9DF3F51BA10A}">
+      <p15:sldGuideLst xmlns:p15="http://schemas.microsoft.com/office/powerpoint/2012/main">
+        <p15:guide id="1" orient="horz" pos="2160">
+          <p15:clr>
+            <a:srgbClr val="A4A3A4"/>
+          </p15:clr>
+        </p15:guide>
+        <p15:guide id="2" pos="2880">
+          <p15:clr>
+            <a:srgbClr val="A4A3A4"/>
+          </p15:clr>
+        </p15:guide>
+      </p15:sldGuideLst>
+    </p:ext>
+  </p:extLst>
 </p:presentation>
 </file>
 
@@ -148,10 +164,9 @@
           <a:lstStyle/>
           <a:p>
             <a:r>
-              <a:rPr lang="en-US" smtClean="0"/>
+              <a:rPr lang="en-US"/>
               <a:t>Click to edit Master title style</a:t>
             </a:r>
-            <a:endParaRPr lang="en-US"/>
           </a:p>
         </p:txBody>
       </p:sp>
@@ -267,10 +282,9 @@
           </a:lstStyle>
           <a:p>
             <a:r>
-              <a:rPr lang="en-US" smtClean="0"/>
+              <a:rPr lang="en-US"/>
               <a:t>Click to edit Master subtitle style</a:t>
             </a:r>
-            <a:endParaRPr lang="en-US"/>
           </a:p>
         </p:txBody>
       </p:sp>
@@ -291,7 +305,7 @@
           <a:p>
             <a:fld id="{5BCAD085-E8A6-8845-BD4E-CB4CCA059FC4}" type="datetimeFigureOut">
               <a:rPr lang="en-US" smtClean="0"/>
-              <a:t>1/27/13</a:t>
+              <a:t>5/22/2026</a:t>
             </a:fld>
             <a:endParaRPr lang="en-US"/>
           </a:p>
@@ -385,10 +399,9 @@
           <a:lstStyle/>
           <a:p>
             <a:r>
-              <a:rPr lang="en-US" smtClean="0"/>
+              <a:rPr lang="en-US"/>
               <a:t>Click to edit Master title style</a:t>
             </a:r>
-            <a:endParaRPr lang="en-US"/>
           </a:p>
         </p:txBody>
       </p:sp>
@@ -409,38 +422,37 @@
           <a:p>
             <a:pPr lvl="0"/>
             <a:r>
-              <a:rPr lang="en-US" smtClean="0"/>
+              <a:rPr lang="en-US"/>
               <a:t>Click to edit Master text styles</a:t>
             </a:r>
           </a:p>
           <a:p>
             <a:pPr lvl="1"/>
             <a:r>
-              <a:rPr lang="en-US" smtClean="0"/>
+              <a:rPr lang="en-US"/>
               <a:t>Second level</a:t>
             </a:r>
           </a:p>
           <a:p>
             <a:pPr lvl="2"/>
             <a:r>
-              <a:rPr lang="en-US" smtClean="0"/>
+              <a:rPr lang="en-US"/>
               <a:t>Third level</a:t>
             </a:r>
           </a:p>
           <a:p>
             <a:pPr lvl="3"/>
             <a:r>
-              <a:rPr lang="en-US" smtClean="0"/>
+              <a:rPr lang="en-US"/>
               <a:t>Fourth level</a:t>
             </a:r>
           </a:p>
           <a:p>
             <a:pPr lvl="4"/>
             <a:r>
-              <a:rPr lang="en-US" smtClean="0"/>
+              <a:rPr lang="en-US"/>
               <a:t>Fifth level</a:t>
             </a:r>
-            <a:endParaRPr lang="en-US"/>
           </a:p>
         </p:txBody>
       </p:sp>
@@ -461,7 +473,7 @@
           <a:p>
             <a:fld id="{5BCAD085-E8A6-8845-BD4E-CB4CCA059FC4}" type="datetimeFigureOut">
               <a:rPr lang="en-US" smtClean="0"/>
-              <a:t>1/27/13</a:t>
+              <a:t>5/22/2026</a:t>
             </a:fld>
             <a:endParaRPr lang="en-US"/>
           </a:p>
@@ -560,10 +572,9 @@
           <a:lstStyle/>
           <a:p>
             <a:r>
-              <a:rPr lang="en-US" smtClean="0"/>
+              <a:rPr lang="en-US"/>
               <a:t>Click to edit Master title style</a:t>
             </a:r>
-            <a:endParaRPr lang="en-US"/>
           </a:p>
         </p:txBody>
       </p:sp>
@@ -589,38 +600,37 @@
           <a:p>
             <a:pPr lvl="0"/>
             <a:r>
-              <a:rPr lang="en-US" smtClean="0"/>
+              <a:rPr lang="en-US"/>
               <a:t>Click to edit Master text styles</a:t>
             </a:r>
           </a:p>
           <a:p>
             <a:pPr lvl="1"/>
             <a:r>
-              <a:rPr lang="en-US" smtClean="0"/>
+              <a:rPr lang="en-US"/>
               <a:t>Second level</a:t>
             </a:r>
           </a:p>
           <a:p>
             <a:pPr lvl="2"/>
             <a:r>
-              <a:rPr lang="en-US" smtClean="0"/>
+              <a:rPr lang="en-US"/>
               <a:t>Third level</a:t>
             </a:r>
           </a:p>
           <a:p>
             <a:pPr lvl="3"/>
             <a:r>
-              <a:rPr lang="en-US" smtClean="0"/>
+              <a:rPr lang="en-US"/>
               <a:t>Fourth level</a:t>
             </a:r>
           </a:p>
           <a:p>
             <a:pPr lvl="4"/>
             <a:r>
-              <a:rPr lang="en-US" smtClean="0"/>
+              <a:rPr lang="en-US"/>
               <a:t>Fifth level</a:t>
             </a:r>
-            <a:endParaRPr lang="en-US"/>
           </a:p>
         </p:txBody>
       </p:sp>
@@ -641,7 +651,7 @@
           <a:p>
             <a:fld id="{5BCAD085-E8A6-8845-BD4E-CB4CCA059FC4}" type="datetimeFigureOut">
               <a:rPr lang="en-US" smtClean="0"/>
-              <a:t>1/27/13</a:t>
+              <a:t>5/22/2026</a:t>
             </a:fld>
             <a:endParaRPr lang="en-US"/>
           </a:p>
@@ -735,10 +745,9 @@
           <a:lstStyle/>
           <a:p>
             <a:r>
-              <a:rPr lang="en-US" smtClean="0"/>
+              <a:rPr lang="en-US"/>
               <a:t>Click to edit Master title style</a:t>
             </a:r>
-            <a:endParaRPr lang="en-US"/>
           </a:p>
         </p:txBody>
       </p:sp>
@@ -759,38 +768,37 @@
           <a:p>
             <a:pPr lvl="0"/>
             <a:r>
-              <a:rPr lang="en-US" smtClean="0"/>
+              <a:rPr lang="en-US"/>
               <a:t>Click to edit Master text styles</a:t>
             </a:r>
           </a:p>
           <a:p>
             <a:pPr lvl="1"/>
             <a:r>
-              <a:rPr lang="en-US" smtClean="0"/>
+              <a:rPr lang="en-US"/>
               <a:t>Second level</a:t>
             </a:r>
           </a:p>
           <a:p>
             <a:pPr lvl="2"/>
             <a:r>
-              <a:rPr lang="en-US" smtClean="0"/>
+              <a:rPr lang="en-US"/>
               <a:t>Third level</a:t>
             </a:r>
           </a:p>
           <a:p>
             <a:pPr lvl="3"/>
             <a:r>
-              <a:rPr lang="en-US" smtClean="0"/>
+              <a:rPr lang="en-US"/>
               <a:t>Fourth level</a:t>
             </a:r>
           </a:p>
           <a:p>
             <a:pPr lvl="4"/>
             <a:r>
-              <a:rPr lang="en-US" smtClean="0"/>
+              <a:rPr lang="en-US"/>
               <a:t>Fifth level</a:t>
             </a:r>
-            <a:endParaRPr lang="en-US"/>
           </a:p>
         </p:txBody>
       </p:sp>
@@ -811,7 +819,7 @@
           <a:p>
             <a:fld id="{5BCAD085-E8A6-8845-BD4E-CB4CCA059FC4}" type="datetimeFigureOut">
               <a:rPr lang="en-US" smtClean="0"/>
-              <a:t>1/27/13</a:t>
+              <a:t>5/22/2026</a:t>
             </a:fld>
             <a:endParaRPr lang="en-US"/>
           </a:p>
@@ -914,10 +922,9 @@
           </a:lstStyle>
           <a:p>
             <a:r>
-              <a:rPr lang="en-US" smtClean="0"/>
+              <a:rPr lang="en-US"/>
               <a:t>Click to edit Master title style</a:t>
             </a:r>
-            <a:endParaRPr lang="en-US"/>
           </a:p>
         </p:txBody>
       </p:sp>
@@ -1034,7 +1041,7 @@
           <a:p>
             <a:pPr lvl="0"/>
             <a:r>
-              <a:rPr lang="en-US" smtClean="0"/>
+              <a:rPr lang="en-US"/>
               <a:t>Click to edit Master text styles</a:t>
             </a:r>
           </a:p>
@@ -1057,7 +1064,7 @@
           <a:p>
             <a:fld id="{5BCAD085-E8A6-8845-BD4E-CB4CCA059FC4}" type="datetimeFigureOut">
               <a:rPr lang="en-US" smtClean="0"/>
-              <a:t>1/27/13</a:t>
+              <a:t>5/22/2026</a:t>
             </a:fld>
             <a:endParaRPr lang="en-US"/>
           </a:p>
@@ -1151,10 +1158,9 @@
           <a:lstStyle/>
           <a:p>
             <a:r>
-              <a:rPr lang="en-US" smtClean="0"/>
+              <a:rPr lang="en-US"/>
               <a:t>Click to edit Master title style</a:t>
             </a:r>
-            <a:endParaRPr lang="en-US"/>
           </a:p>
         </p:txBody>
       </p:sp>
@@ -1208,38 +1214,37 @@
           <a:p>
             <a:pPr lvl="0"/>
             <a:r>
-              <a:rPr lang="en-US" smtClean="0"/>
+              <a:rPr lang="en-US"/>
               <a:t>Click to edit Master text styles</a:t>
             </a:r>
           </a:p>
           <a:p>
             <a:pPr lvl="1"/>
             <a:r>
-              <a:rPr lang="en-US" smtClean="0"/>
+              <a:rPr lang="en-US"/>
               <a:t>Second level</a:t>
             </a:r>
           </a:p>
           <a:p>
             <a:pPr lvl="2"/>
             <a:r>
-              <a:rPr lang="en-US" smtClean="0"/>
+              <a:rPr lang="en-US"/>
               <a:t>Third level</a:t>
             </a:r>
           </a:p>
           <a:p>
             <a:pPr lvl="3"/>
             <a:r>
-              <a:rPr lang="en-US" smtClean="0"/>
+              <a:rPr lang="en-US"/>
               <a:t>Fourth level</a:t>
             </a:r>
           </a:p>
           <a:p>
             <a:pPr lvl="4"/>
             <a:r>
-              <a:rPr lang="en-US" smtClean="0"/>
+              <a:rPr lang="en-US"/>
               <a:t>Fifth level</a:t>
             </a:r>
-            <a:endParaRPr lang="en-US"/>
           </a:p>
         </p:txBody>
       </p:sp>
@@ -1293,38 +1298,37 @@
           <a:p>
             <a:pPr lvl="0"/>
             <a:r>
-              <a:rPr lang="en-US" smtClean="0"/>
+              <a:rPr lang="en-US"/>
               <a:t>Click to edit Master text styles</a:t>
             </a:r>
           </a:p>
           <a:p>
             <a:pPr lvl="1"/>
             <a:r>
-              <a:rPr lang="en-US" smtClean="0"/>
+              <a:rPr lang="en-US"/>
               <a:t>Second level</a:t>
             </a:r>
           </a:p>
           <a:p>
             <a:pPr lvl="2"/>
             <a:r>
-              <a:rPr lang="en-US" smtClean="0"/>
+              <a:rPr lang="en-US"/>
               <a:t>Third level</a:t>
             </a:r>
           </a:p>
           <a:p>
             <a:pPr lvl="3"/>
             <a:r>
-              <a:rPr lang="en-US" smtClean="0"/>
+              <a:rPr lang="en-US"/>
               <a:t>Fourth level</a:t>
             </a:r>
           </a:p>
           <a:p>
             <a:pPr lvl="4"/>
             <a:r>
-              <a:rPr lang="en-US" smtClean="0"/>
+              <a:rPr lang="en-US"/>
               <a:t>Fifth level</a:t>
             </a:r>
-            <a:endParaRPr lang="en-US"/>
           </a:p>
         </p:txBody>
       </p:sp>
@@ -1345,7 +1349,7 @@
           <a:p>
             <a:fld id="{5BCAD085-E8A6-8845-BD4E-CB4CCA059FC4}" type="datetimeFigureOut">
               <a:rPr lang="en-US" smtClean="0"/>
-              <a:t>1/27/13</a:t>
+              <a:t>5/22/2026</a:t>
             </a:fld>
             <a:endParaRPr lang="en-US"/>
           </a:p>
@@ -1443,10 +1447,9 @@
           </a:lstStyle>
           <a:p>
             <a:r>
-              <a:rPr lang="en-US" smtClean="0"/>
+              <a:rPr lang="en-US"/>
               <a:t>Click to edit Master title style</a:t>
             </a:r>
-            <a:endParaRPr lang="en-US"/>
           </a:p>
         </p:txBody>
       </p:sp>
@@ -1509,7 +1512,7 @@
           <a:p>
             <a:pPr lvl="0"/>
             <a:r>
-              <a:rPr lang="en-US" smtClean="0"/>
+              <a:rPr lang="en-US"/>
               <a:t>Click to edit Master text styles</a:t>
             </a:r>
           </a:p>
@@ -1565,38 +1568,37 @@
           <a:p>
             <a:pPr lvl="0"/>
             <a:r>
-              <a:rPr lang="en-US" smtClean="0"/>
+              <a:rPr lang="en-US"/>
               <a:t>Click to edit Master text styles</a:t>
             </a:r>
           </a:p>
           <a:p>
             <a:pPr lvl="1"/>
             <a:r>
-              <a:rPr lang="en-US" smtClean="0"/>
+              <a:rPr lang="en-US"/>
               <a:t>Second level</a:t>
             </a:r>
           </a:p>
           <a:p>
             <a:pPr lvl="2"/>
             <a:r>
-              <a:rPr lang="en-US" smtClean="0"/>
+              <a:rPr lang="en-US"/>
               <a:t>Third level</a:t>
             </a:r>
           </a:p>
           <a:p>
             <a:pPr lvl="3"/>
             <a:r>
-              <a:rPr lang="en-US" smtClean="0"/>
+              <a:rPr lang="en-US"/>
               <a:t>Fourth level</a:t>
             </a:r>
           </a:p>
           <a:p>
             <a:pPr lvl="4"/>
             <a:r>
-              <a:rPr lang="en-US" smtClean="0"/>
+              <a:rPr lang="en-US"/>
               <a:t>Fifth level</a:t>
             </a:r>
-            <a:endParaRPr lang="en-US"/>
           </a:p>
         </p:txBody>
       </p:sp>
@@ -1659,7 +1661,7 @@
           <a:p>
             <a:pPr lvl="0"/>
             <a:r>
-              <a:rPr lang="en-US" smtClean="0"/>
+              <a:rPr lang="en-US"/>
               <a:t>Click to edit Master text styles</a:t>
             </a:r>
           </a:p>
@@ -1715,38 +1717,37 @@
           <a:p>
             <a:pPr lvl="0"/>
             <a:r>
-              <a:rPr lang="en-US" smtClean="0"/>
+              <a:rPr lang="en-US"/>
               <a:t>Click to edit Master text styles</a:t>
             </a:r>
           </a:p>
           <a:p>
             <a:pPr lvl="1"/>
             <a:r>
-              <a:rPr lang="en-US" smtClean="0"/>
+              <a:rPr lang="en-US"/>
               <a:t>Second level</a:t>
             </a:r>
           </a:p>
           <a:p>
             <a:pPr lvl="2"/>
             <a:r>
-              <a:rPr lang="en-US" smtClean="0"/>
+              <a:rPr lang="en-US"/>
               <a:t>Third level</a:t>
             </a:r>
           </a:p>
           <a:p>
             <a:pPr lvl="3"/>
             <a:r>
-              <a:rPr lang="en-US" smtClean="0"/>
+              <a:rPr lang="en-US"/>
               <a:t>Fourth level</a:t>
             </a:r>
           </a:p>
           <a:p>
             <a:pPr lvl="4"/>
             <a:r>
-              <a:rPr lang="en-US" smtClean="0"/>
+              <a:rPr lang="en-US"/>
               <a:t>Fifth level</a:t>
             </a:r>
-            <a:endParaRPr lang="en-US"/>
           </a:p>
         </p:txBody>
       </p:sp>
@@ -1767,7 +1768,7 @@
           <a:p>
             <a:fld id="{5BCAD085-E8A6-8845-BD4E-CB4CCA059FC4}" type="datetimeFigureOut">
               <a:rPr lang="en-US" smtClean="0"/>
-              <a:t>1/27/13</a:t>
+              <a:t>5/22/2026</a:t>
             </a:fld>
             <a:endParaRPr lang="en-US"/>
           </a:p>
@@ -1861,10 +1862,9 @@
           <a:lstStyle/>
           <a:p>
             <a:r>
-              <a:rPr lang="en-US" smtClean="0"/>
+              <a:rPr lang="en-US"/>
               <a:t>Click to edit Master title style</a:t>
             </a:r>
-            <a:endParaRPr lang="en-US"/>
           </a:p>
         </p:txBody>
       </p:sp>
@@ -1885,7 +1885,7 @@
           <a:p>
             <a:fld id="{5BCAD085-E8A6-8845-BD4E-CB4CCA059FC4}" type="datetimeFigureOut">
               <a:rPr lang="en-US" smtClean="0"/>
-              <a:t>1/27/13</a:t>
+              <a:t>5/22/2026</a:t>
             </a:fld>
             <a:endParaRPr lang="en-US"/>
           </a:p>
@@ -1980,7 +1980,7 @@
           <a:p>
             <a:fld id="{5BCAD085-E8A6-8845-BD4E-CB4CCA059FC4}" type="datetimeFigureOut">
               <a:rPr lang="en-US" smtClean="0"/>
-              <a:t>1/27/13</a:t>
+              <a:t>5/22/2026</a:t>
             </a:fld>
             <a:endParaRPr lang="en-US"/>
           </a:p>
@@ -2083,10 +2083,9 @@
           </a:lstStyle>
           <a:p>
             <a:r>
-              <a:rPr lang="en-US" smtClean="0"/>
+              <a:rPr lang="en-US"/>
               <a:t>Click to edit Master title style</a:t>
             </a:r>
-            <a:endParaRPr lang="en-US"/>
           </a:p>
         </p:txBody>
       </p:sp>
@@ -2140,38 +2139,37 @@
           <a:p>
             <a:pPr lvl="0"/>
             <a:r>
-              <a:rPr lang="en-US" smtClean="0"/>
+              <a:rPr lang="en-US"/>
               <a:t>Click to edit Master text styles</a:t>
             </a:r>
           </a:p>
           <a:p>
             <a:pPr lvl="1"/>
             <a:r>
-              <a:rPr lang="en-US" smtClean="0"/>
+              <a:rPr lang="en-US"/>
               <a:t>Second level</a:t>
             </a:r>
           </a:p>
           <a:p>
             <a:pPr lvl="2"/>
             <a:r>
-              <a:rPr lang="en-US" smtClean="0"/>
+              <a:rPr lang="en-US"/>
               <a:t>Third level</a:t>
             </a:r>
           </a:p>
           <a:p>
             <a:pPr lvl="3"/>
             <a:r>
-              <a:rPr lang="en-US" smtClean="0"/>
+              <a:rPr lang="en-US"/>
               <a:t>Fourth level</a:t>
             </a:r>
           </a:p>
           <a:p>
             <a:pPr lvl="4"/>
             <a:r>
-              <a:rPr lang="en-US" smtClean="0"/>
+              <a:rPr lang="en-US"/>
               <a:t>Fifth level</a:t>
             </a:r>
-            <a:endParaRPr lang="en-US"/>
           </a:p>
         </p:txBody>
       </p:sp>
@@ -2234,7 +2232,7 @@
           <a:p>
             <a:pPr lvl="0"/>
             <a:r>
-              <a:rPr lang="en-US" smtClean="0"/>
+              <a:rPr lang="en-US"/>
               <a:t>Click to edit Master text styles</a:t>
             </a:r>
           </a:p>
@@ -2257,7 +2255,7 @@
           <a:p>
             <a:fld id="{5BCAD085-E8A6-8845-BD4E-CB4CCA059FC4}" type="datetimeFigureOut">
               <a:rPr lang="en-US" smtClean="0"/>
-              <a:t>1/27/13</a:t>
+              <a:t>5/22/2026</a:t>
             </a:fld>
             <a:endParaRPr lang="en-US"/>
           </a:p>
@@ -2360,10 +2358,9 @@
           </a:lstStyle>
           <a:p>
             <a:r>
-              <a:rPr lang="en-US" smtClean="0"/>
+              <a:rPr lang="en-US"/>
               <a:t>Click to edit Master title style</a:t>
             </a:r>
-            <a:endParaRPr lang="en-US"/>
           </a:p>
         </p:txBody>
       </p:sp>
@@ -2487,7 +2484,7 @@
           <a:p>
             <a:pPr lvl="0"/>
             <a:r>
-              <a:rPr lang="en-US" smtClean="0"/>
+              <a:rPr lang="en-US"/>
               <a:t>Click to edit Master text styles</a:t>
             </a:r>
           </a:p>
@@ -2510,7 +2507,7 @@
           <a:p>
             <a:fld id="{5BCAD085-E8A6-8845-BD4E-CB4CCA059FC4}" type="datetimeFigureOut">
               <a:rPr lang="en-US" smtClean="0"/>
-              <a:t>1/27/13</a:t>
+              <a:t>5/22/2026</a:t>
             </a:fld>
             <a:endParaRPr lang="en-US"/>
           </a:p>
@@ -2619,10 +2616,9 @@
           <a:lstStyle/>
           <a:p>
             <a:r>
-              <a:rPr lang="en-US" smtClean="0"/>
+              <a:rPr lang="en-US"/>
               <a:t>Click to edit Master title style</a:t>
             </a:r>
-            <a:endParaRPr lang="en-US"/>
           </a:p>
         </p:txBody>
       </p:sp>
@@ -2653,38 +2649,37 @@
           <a:p>
             <a:pPr lvl="0"/>
             <a:r>
-              <a:rPr lang="en-US" smtClean="0"/>
+              <a:rPr lang="en-US"/>
               <a:t>Click to edit Master text styles</a:t>
             </a:r>
           </a:p>
           <a:p>
             <a:pPr lvl="1"/>
             <a:r>
-              <a:rPr lang="en-US" smtClean="0"/>
+              <a:rPr lang="en-US"/>
               <a:t>Second level</a:t>
             </a:r>
           </a:p>
           <a:p>
             <a:pPr lvl="2"/>
             <a:r>
-              <a:rPr lang="en-US" smtClean="0"/>
+              <a:rPr lang="en-US"/>
               <a:t>Third level</a:t>
             </a:r>
           </a:p>
           <a:p>
             <a:pPr lvl="3"/>
             <a:r>
-              <a:rPr lang="en-US" smtClean="0"/>
+              <a:rPr lang="en-US"/>
               <a:t>Fourth level</a:t>
             </a:r>
           </a:p>
           <a:p>
             <a:pPr lvl="4"/>
             <a:r>
-              <a:rPr lang="en-US" smtClean="0"/>
+              <a:rPr lang="en-US"/>
               <a:t>Fifth level</a:t>
             </a:r>
-            <a:endParaRPr lang="en-US"/>
           </a:p>
         </p:txBody>
       </p:sp>
@@ -2723,7 +2718,7 @@
           <a:p>
             <a:fld id="{5BCAD085-E8A6-8845-BD4E-CB4CCA059FC4}" type="datetimeFigureOut">
               <a:rPr lang="en-US" smtClean="0"/>
-              <a:t>1/27/13</a:t>
+              <a:t>5/22/2026</a:t>
             </a:fld>
             <a:endParaRPr lang="en-US"/>
           </a:p>
@@ -3082,7 +3077,7 @@
 </file>
 
 <file path=ppt/slides/slide1.xml><?xml version="1.0" encoding="utf-8"?>
-<p:sld xmlns:a="http://schemas.openxmlformats.org/drawingml/2006/main" xmlns:p="http://schemas.openxmlformats.org/presentationml/2006/main" xmlns:r="http://schemas.openxmlformats.org/officeDocument/2006/relationships">
+<p:sld xmlns:a="http://schemas.openxmlformats.org/drawingml/2006/main" xmlns:r="http://schemas.openxmlformats.org/officeDocument/2006/relationships" xmlns:p="http://schemas.openxmlformats.org/presentationml/2006/main">
   <p:cSld>
     <p:spTree>
       <p:nvGrpSpPr>
@@ -3090,7 +3085,14 @@
         <p:cNvGrpSpPr/>
         <p:nvPr/>
       </p:nvGrpSpPr>
-      <p:grpSpPr/>
+      <p:grpSpPr>
+        <a:xfrm>
+          <a:off x="0" y="0"/>
+          <a:ext cx="0" cy="0"/>
+          <a:chOff x="0" y="0"/>
+          <a:chExt cx="0" cy="0"/>
+        </a:xfrm>
+      </p:grpSpPr>
       <p:sp>
         <p:nvSpPr>
           <p:cNvPr id="2" name="TextBox 1"/>
@@ -3168,7 +3170,7 @@
 </file>
 
 <file path=ppt/slides/slide2.xml><?xml version="1.0" encoding="utf-8"?>
-<p:sld xmlns:a="http://schemas.openxmlformats.org/drawingml/2006/main" xmlns:p="http://schemas.openxmlformats.org/presentationml/2006/main" xmlns:r="http://schemas.openxmlformats.org/officeDocument/2006/relationships">
+<p:sld xmlns:a="http://schemas.openxmlformats.org/drawingml/2006/main" xmlns:r="http://schemas.openxmlformats.org/officeDocument/2006/relationships" xmlns:p="http://schemas.openxmlformats.org/presentationml/2006/main">
   <p:cSld>
     <p:spTree>
       <p:nvGrpSpPr>
@@ -3176,7 +3178,14 @@
         <p:cNvGrpSpPr/>
         <p:nvPr/>
       </p:nvGrpSpPr>
-      <p:grpSpPr/>
+      <p:grpSpPr>
+        <a:xfrm>
+          <a:off x="0" y="0"/>
+          <a:ext cx="0" cy="0"/>
+          <a:chOff x="0" y="0"/>
+          <a:chExt cx="0" cy="0"/>
+        </a:xfrm>
+      </p:grpSpPr>
       <p:sp>
         <p:nvSpPr>
           <p:cNvPr id="2" name="Rectangle 1"/>
@@ -3213,7 +3222,7 @@
           </a:fontRef>
         </p:style>
         <p:txBody>
-          <a:bodyPr rtlCol="0" anchor="ctr" lIns="182880" rIns="182880"/>
+          <a:bodyPr lIns="182880" rIns="182880" rtlCol="0" anchor="ctr"/>
           <a:lstStyle/>
           <a:p>
             <a:pPr algn="ctr"/>
@@ -3268,7 +3277,7 @@
           </a:fontRef>
         </p:style>
         <p:txBody>
-          <a:bodyPr rtlCol="0" anchor="ctr" lIns="45720" rIns="45720"/>
+          <a:bodyPr lIns="45720" rIns="45720" rtlCol="0" anchor="ctr"/>
           <a:lstStyle/>
           <a:p>
             <a:pPr algn="ctr"/>
@@ -3354,7 +3363,7 @@
           </a:fontRef>
         </p:style>
         <p:txBody>
-          <a:bodyPr rtlCol="0" anchor="ctr" lIns="45720" rIns="45720"/>
+          <a:bodyPr lIns="45720" rIns="45720" rtlCol="0" anchor="ctr"/>
           <a:lstStyle/>
           <a:p>
             <a:pPr algn="ctr"/>
@@ -3440,7 +3449,7 @@
           </a:fontRef>
         </p:style>
         <p:txBody>
-          <a:bodyPr rtlCol="0" anchor="ctr" lIns="45720" rIns="45720"/>
+          <a:bodyPr lIns="45720" rIns="45720" rtlCol="0" anchor="ctr"/>
           <a:lstStyle/>
           <a:p>
             <a:pPr algn="ctr"/>
@@ -3542,7 +3551,7 @@
           </a:fontRef>
         </p:style>
         <p:txBody>
-          <a:bodyPr rtlCol="0" anchor="ctr" lIns="45720" rIns="45720"/>
+          <a:bodyPr lIns="45720" rIns="45720" rtlCol="0" anchor="ctr"/>
           <a:lstStyle/>
           <a:p>
             <a:pPr algn="ctr"/>
@@ -3636,7 +3645,7 @@
           </a:fontRef>
         </p:style>
         <p:txBody>
-          <a:bodyPr rtlCol="0" anchor="ctr" lIns="45720" rIns="45720"/>
+          <a:bodyPr lIns="45720" rIns="45720" rtlCol="0" anchor="ctr"/>
           <a:lstStyle/>
           <a:p>
             <a:pPr algn="ctr"/>
@@ -3730,7 +3739,7 @@
           </a:fontRef>
         </p:style>
         <p:txBody>
-          <a:bodyPr rtlCol="0" anchor="ctr" lIns="45720" rIns="45720"/>
+          <a:bodyPr lIns="45720" rIns="45720" rtlCol="0" anchor="ctr"/>
           <a:lstStyle/>
           <a:p>
             <a:pPr algn="ctr"/>
@@ -3840,7 +3849,7 @@
           </a:fontRef>
         </p:style>
         <p:txBody>
-          <a:bodyPr rtlCol="0" anchor="ctr" lIns="45720" rIns="45720"/>
+          <a:bodyPr lIns="45720" rIns="45720" rtlCol="0" anchor="ctr"/>
           <a:lstStyle/>
           <a:p>
             <a:pPr algn="ctr"/>
@@ -3942,7 +3951,7 @@
           </a:fontRef>
         </p:style>
         <p:txBody>
-          <a:bodyPr rtlCol="0" anchor="ctr" lIns="45720" rIns="45720"/>
+          <a:bodyPr lIns="45720" rIns="45720" rtlCol="0" anchor="ctr"/>
           <a:lstStyle/>
           <a:p>
             <a:pPr algn="ctr"/>
@@ -4036,7 +4045,7 @@
           </a:fontRef>
         </p:style>
         <p:txBody>
-          <a:bodyPr rtlCol="0" anchor="ctr" lIns="45720" rIns="45720"/>
+          <a:bodyPr lIns="45720" rIns="45720" rtlCol="0" anchor="ctr"/>
           <a:lstStyle/>
           <a:p>
             <a:pPr algn="ctr"/>
@@ -4122,7 +4131,7 @@
           </a:fontRef>
         </p:style>
         <p:txBody>
-          <a:bodyPr rtlCol="0" anchor="ctr" lIns="45720" rIns="45720"/>
+          <a:bodyPr lIns="45720" rIns="45720" rtlCol="0" anchor="ctr"/>
           <a:lstStyle/>
           <a:p>
             <a:pPr algn="ctr"/>
@@ -4232,7 +4241,7 @@
           </a:fontRef>
         </p:style>
         <p:txBody>
-          <a:bodyPr rtlCol="0" anchor="ctr" lIns="45720" rIns="45720"/>
+          <a:bodyPr lIns="45720" rIns="45720" rtlCol="0" anchor="ctr"/>
           <a:lstStyle/>
           <a:p>
             <a:pPr algn="ctr"/>
@@ -4318,7 +4327,7 @@
           </a:fontRef>
         </p:style>
         <p:txBody>
-          <a:bodyPr rtlCol="0" anchor="ctr" lIns="45720" rIns="45720"/>
+          <a:bodyPr lIns="45720" rIns="45720" rtlCol="0" anchor="ctr"/>
           <a:lstStyle/>
           <a:p>
             <a:pPr algn="ctr"/>
@@ -4428,7 +4437,7 @@
           </a:fontRef>
         </p:style>
         <p:txBody>
-          <a:bodyPr rtlCol="0" anchor="ctr" lIns="45720" rIns="45720"/>
+          <a:bodyPr lIns="45720" rIns="45720" rtlCol="0" anchor="ctr"/>
           <a:lstStyle/>
           <a:p>
             <a:pPr algn="ctr"/>
@@ -4538,7 +4547,7 @@
           </a:fontRef>
         </p:style>
         <p:txBody>
-          <a:bodyPr rtlCol="0" anchor="ctr" lIns="45720" rIns="45720"/>
+          <a:bodyPr lIns="45720" rIns="45720" rtlCol="0" anchor="ctr"/>
           <a:lstStyle/>
           <a:p>
             <a:pPr algn="ctr"/>
@@ -4648,7 +4657,7 @@
           </a:fontRef>
         </p:style>
         <p:txBody>
-          <a:bodyPr rtlCol="0" anchor="ctr" lIns="45720" rIns="45720"/>
+          <a:bodyPr lIns="45720" rIns="45720" rtlCol="0" anchor="ctr"/>
           <a:lstStyle/>
           <a:p>
             <a:pPr algn="ctr"/>
@@ -4711,7 +4720,7 @@
 </file>
 
 <file path=ppt/slides/slide3.xml><?xml version="1.0" encoding="utf-8"?>
-<p:sld xmlns:a="http://schemas.openxmlformats.org/drawingml/2006/main" xmlns:p="http://schemas.openxmlformats.org/presentationml/2006/main" xmlns:r="http://schemas.openxmlformats.org/officeDocument/2006/relationships">
+<p:sld xmlns:a="http://schemas.openxmlformats.org/drawingml/2006/main" xmlns:r="http://schemas.openxmlformats.org/officeDocument/2006/relationships" xmlns:p="http://schemas.openxmlformats.org/presentationml/2006/main">
   <p:cSld>
     <p:spTree>
       <p:nvGrpSpPr>
@@ -4719,7 +4728,14 @@
         <p:cNvGrpSpPr/>
         <p:nvPr/>
       </p:nvGrpSpPr>
-      <p:grpSpPr/>
+      <p:grpSpPr>
+        <a:xfrm>
+          <a:off x="0" y="0"/>
+          <a:ext cx="0" cy="0"/>
+          <a:chOff x="0" y="0"/>
+          <a:chExt cx="0" cy="0"/>
+        </a:xfrm>
+      </p:grpSpPr>
       <p:sp>
         <p:nvSpPr>
           <p:cNvPr id="2" name="Rectangle 1"/>
@@ -4756,7 +4772,7 @@
           </a:fontRef>
         </p:style>
         <p:txBody>
-          <a:bodyPr rtlCol="0" anchor="ctr" lIns="182880" rIns="182880"/>
+          <a:bodyPr lIns="182880" rIns="182880" rtlCol="0" anchor="ctr"/>
           <a:lstStyle/>
           <a:p>
             <a:pPr algn="ctr"/>
@@ -4811,7 +4827,7 @@
           </a:fontRef>
         </p:style>
         <p:txBody>
-          <a:bodyPr rtlCol="0" anchor="ctr" lIns="45720" rIns="45720"/>
+          <a:bodyPr lIns="45720" rIns="45720" rtlCol="0" anchor="ctr"/>
           <a:lstStyle/>
           <a:p>
             <a:pPr algn="ctr"/>
@@ -4921,7 +4937,7 @@
           </a:fontRef>
         </p:style>
         <p:txBody>
-          <a:bodyPr rtlCol="0" anchor="ctr" lIns="45720" rIns="45720"/>
+          <a:bodyPr lIns="45720" rIns="45720" rtlCol="0" anchor="ctr"/>
           <a:lstStyle/>
           <a:p>
             <a:pPr algn="ctr"/>
@@ -5015,7 +5031,7 @@
           </a:fontRef>
         </p:style>
         <p:txBody>
-          <a:bodyPr rtlCol="0" anchor="ctr" lIns="45720" rIns="45720"/>
+          <a:bodyPr lIns="45720" rIns="45720" rtlCol="0" anchor="ctr"/>
           <a:lstStyle/>
           <a:p>
             <a:pPr algn="ctr"/>
@@ -5125,7 +5141,7 @@
           </a:fontRef>
         </p:style>
         <p:txBody>
-          <a:bodyPr rtlCol="0" anchor="ctr" lIns="45720" rIns="45720"/>
+          <a:bodyPr lIns="45720" rIns="45720" rtlCol="0" anchor="ctr"/>
           <a:lstStyle/>
           <a:p>
             <a:pPr algn="ctr"/>
@@ -5211,7 +5227,7 @@
           </a:fontRef>
         </p:style>
         <p:txBody>
-          <a:bodyPr rtlCol="0" anchor="ctr" lIns="45720" rIns="45720"/>
+          <a:bodyPr lIns="45720" rIns="45720" rtlCol="0" anchor="ctr"/>
           <a:lstStyle/>
           <a:p>
             <a:pPr algn="ctr"/>
@@ -5297,7 +5313,7 @@
           </a:fontRef>
         </p:style>
         <p:txBody>
-          <a:bodyPr rtlCol="0" anchor="ctr" lIns="45720" rIns="45720"/>
+          <a:bodyPr lIns="45720" rIns="45720" rtlCol="0" anchor="ctr"/>
           <a:lstStyle/>
           <a:p>
             <a:pPr algn="ctr"/>
@@ -5407,7 +5423,7 @@
           </a:fontRef>
         </p:style>
         <p:txBody>
-          <a:bodyPr rtlCol="0" anchor="ctr" lIns="45720" rIns="45720"/>
+          <a:bodyPr lIns="45720" rIns="45720" rtlCol="0" anchor="ctr"/>
           <a:lstStyle/>
           <a:p>
             <a:pPr algn="ctr"/>
@@ -5501,7 +5517,7 @@
           </a:fontRef>
         </p:style>
         <p:txBody>
-          <a:bodyPr rtlCol="0" anchor="ctr" lIns="45720" rIns="45720"/>
+          <a:bodyPr lIns="45720" rIns="45720" rtlCol="0" anchor="ctr"/>
           <a:lstStyle/>
           <a:p>
             <a:pPr algn="ctr"/>
@@ -5595,7 +5611,7 @@
           </a:fontRef>
         </p:style>
         <p:txBody>
-          <a:bodyPr rtlCol="0" anchor="ctr" lIns="45720" rIns="45720"/>
+          <a:bodyPr lIns="45720" rIns="45720" rtlCol="0" anchor="ctr"/>
           <a:lstStyle/>
           <a:p>
             <a:pPr algn="ctr"/>
@@ -5697,7 +5713,7 @@
           </a:fontRef>
         </p:style>
         <p:txBody>
-          <a:bodyPr rtlCol="0" anchor="ctr" lIns="45720" rIns="45720"/>
+          <a:bodyPr lIns="45720" rIns="45720" rtlCol="0" anchor="ctr"/>
           <a:lstStyle/>
           <a:p>
             <a:pPr algn="ctr"/>
@@ -5807,7 +5823,7 @@
           </a:fontRef>
         </p:style>
         <p:txBody>
-          <a:bodyPr rtlCol="0" anchor="ctr" lIns="45720" rIns="45720"/>
+          <a:bodyPr lIns="45720" rIns="45720" rtlCol="0" anchor="ctr"/>
           <a:lstStyle/>
           <a:p>
             <a:pPr algn="ctr"/>
@@ -5893,7 +5909,7 @@
           </a:fontRef>
         </p:style>
         <p:txBody>
-          <a:bodyPr rtlCol="0" anchor="ctr" lIns="45720" rIns="45720"/>
+          <a:bodyPr lIns="45720" rIns="45720" rtlCol="0" anchor="ctr"/>
           <a:lstStyle/>
           <a:p>
             <a:pPr algn="ctr"/>
@@ -5979,7 +5995,7 @@
           </a:fontRef>
         </p:style>
         <p:txBody>
-          <a:bodyPr rtlCol="0" anchor="ctr" lIns="45720" rIns="45720"/>
+          <a:bodyPr lIns="45720" rIns="45720" rtlCol="0" anchor="ctr"/>
           <a:lstStyle/>
           <a:p>
             <a:pPr algn="ctr"/>
@@ -6065,18 +6081,47 @@
           </a:fontRef>
         </p:style>
         <p:txBody>
-          <a:bodyPr rtlCol="0" anchor="ctr" lIns="45720" rIns="45720"/>
+          <a:bodyPr lIns="45720" rIns="45720" rtlCol="0" anchor="ctr"/>
           <a:lstStyle/>
           <a:p>
             <a:pPr algn="ctr"/>
             <a:r>
-              <a:rPr sz="900">
+              <a:rPr sz="900" dirty="0">
                 <a:solidFill>
                   <a:srgbClr val="1F3A5F"/>
                 </a:solidFill>
               </a:rPr>
-              <a:t>Gram 35: FR Tantive IV, Category 4, Romulus</a:t>
-            </a:r>
+              <a:t>Gram 35: FR </a:t>
+            </a:r>
+            <a:r>
+              <a:rPr sz="900" dirty="0" err="1">
+                <a:solidFill>
+                  <a:srgbClr val="1F3A5F"/>
+                </a:solidFill>
+              </a:rPr>
+              <a:t>Tantive</a:t>
+            </a:r>
+            <a:r>
+              <a:rPr sz="900" dirty="0">
+                <a:solidFill>
+                  <a:srgbClr val="1F3A5F"/>
+                </a:solidFill>
+              </a:rPr>
+              <a:t> IV, Category 4, Romulus</a:t>
+            </a:r>
+            <a:r>
+              <a:rPr lang="en-GB" sz="900" dirty="0">
+                <a:solidFill>
+                  <a:srgbClr val="1F3A5F"/>
+                </a:solidFill>
+              </a:rPr>
+              <a:t> [-own]</a:t>
+            </a:r>
+            <a:endParaRPr sz="900" dirty="0">
+              <a:solidFill>
+                <a:srgbClr val="1F3A5F"/>
+              </a:solidFill>
+            </a:endParaRPr>
           </a:p>
         </p:txBody>
       </p:sp>
@@ -6175,18 +6220,39 @@
           </a:fontRef>
         </p:style>
         <p:txBody>
-          <a:bodyPr rtlCol="0" anchor="ctr" lIns="45720" rIns="45720"/>
+          <a:bodyPr lIns="45720" rIns="45720" rtlCol="0" anchor="ctr"/>
           <a:lstStyle/>
           <a:p>
             <a:pPr algn="ctr"/>
             <a:r>
-              <a:rPr sz="900">
+              <a:rPr sz="900" dirty="0">
                 <a:solidFill>
                   <a:srgbClr val="1F3A5F"/>
                 </a:solidFill>
               </a:rPr>
-              <a:t>Gram 36: Equinox contact bearing 209, codename Kobol</a:t>
-            </a:r>
+              <a:t>Gram 36: Equinox contact bearing 209, codename </a:t>
+            </a:r>
+            <a:r>
+              <a:rPr sz="900" dirty="0" err="1">
+                <a:solidFill>
+                  <a:srgbClr val="1F3A5F"/>
+                </a:solidFill>
+              </a:rPr>
+              <a:t>Kobol</a:t>
+            </a:r>
+            <a:r>
+              <a:rPr lang="en-GB" sz="900" dirty="0">
+                <a:solidFill>
+                  <a:srgbClr val="1F3A5F"/>
+                </a:solidFill>
+              </a:rPr>
+              <a:t> [-other]</a:t>
+            </a:r>
+            <a:endParaRPr sz="900" dirty="0">
+              <a:solidFill>
+                <a:srgbClr val="1F3A5F"/>
+              </a:solidFill>
+            </a:endParaRPr>
           </a:p>
         </p:txBody>
       </p:sp>
@@ -6246,7 +6312,7 @@
 </file>
 
 <file path=ppt/slides/slide4.xml><?xml version="1.0" encoding="utf-8"?>
-<p:sld xmlns:a="http://schemas.openxmlformats.org/drawingml/2006/main" xmlns:p="http://schemas.openxmlformats.org/presentationml/2006/main" xmlns:r="http://schemas.openxmlformats.org/officeDocument/2006/relationships">
+<p:sld xmlns:a="http://schemas.openxmlformats.org/drawingml/2006/main" xmlns:r="http://schemas.openxmlformats.org/officeDocument/2006/relationships" xmlns:p="http://schemas.openxmlformats.org/presentationml/2006/main">
   <p:cSld>
     <p:spTree>
       <p:nvGrpSpPr>
@@ -6254,7 +6320,14 @@
         <p:cNvGrpSpPr/>
         <p:nvPr/>
       </p:nvGrpSpPr>
-      <p:grpSpPr/>
+      <p:grpSpPr>
+        <a:xfrm>
+          <a:off x="0" y="0"/>
+          <a:ext cx="0" cy="0"/>
+          <a:chOff x="0" y="0"/>
+          <a:chExt cx="0" cy="0"/>
+        </a:xfrm>
+      </p:grpSpPr>
       <p:sp>
         <p:nvSpPr>
           <p:cNvPr id="2" name="TextBox 1"/>

</xml_diff>